<commit_message>
Fix Sharpe ratio: RF updated from 27% to 15.06% avg CBE rate (2014-2025)
</commit_message>
<xml_diff>
--- a/report/EGX30_Presentation.pptx
+++ b/report/EGX30_Presentation.pptx
@@ -4135,6 +4135,10 @@
             <a:prstDash val="solid"/>
           </a:ln>
         </p:spPr>
+        <p:txBody>
+          <a:bodyPr/>
+          <a:p/>
+        </p:txBody>
       </p:sp>
       <p:sp>
         <p:nvSpPr>
@@ -4238,6 +4242,10 @@
             <a:prstDash val="solid"/>
           </a:ln>
         </p:spPr>
+        <p:txBody>
+          <a:bodyPr/>
+          <a:p/>
+        </p:txBody>
       </p:sp>
       <p:sp>
         <p:nvSpPr>
@@ -4458,6 +4466,10 @@
             </a:outerShdw>
           </a:effectLst>
         </p:spPr>
+        <p:txBody>
+          <a:bodyPr/>
+          <a:p/>
+        </p:txBody>
       </p:sp>
       <p:sp>
         <p:nvSpPr>
@@ -4483,6 +4495,10 @@
             <a:prstDash val="solid"/>
           </a:ln>
         </p:spPr>
+        <p:txBody>
+          <a:bodyPr/>
+          <a:p/>
+        </p:txBody>
       </p:sp>
       <p:sp>
         <p:nvSpPr>
@@ -4593,6 +4609,10 @@
             </a:outerShdw>
           </a:effectLst>
         </p:spPr>
+        <p:txBody>
+          <a:bodyPr/>
+          <a:p/>
+        </p:txBody>
       </p:sp>
       <p:sp>
         <p:nvSpPr>
@@ -4618,6 +4638,10 @@
             <a:prstDash val="solid"/>
           </a:ln>
         </p:spPr>
+        <p:txBody>
+          <a:bodyPr/>
+          <a:p/>
+        </p:txBody>
       </p:sp>
       <p:sp>
         <p:nvSpPr>
@@ -4728,6 +4752,10 @@
             </a:outerShdw>
           </a:effectLst>
         </p:spPr>
+        <p:txBody>
+          <a:bodyPr/>
+          <a:p/>
+        </p:txBody>
       </p:sp>
       <p:sp>
         <p:nvSpPr>
@@ -4753,6 +4781,10 @@
             <a:prstDash val="solid"/>
           </a:ln>
         </p:spPr>
+        <p:txBody>
+          <a:bodyPr/>
+          <a:p/>
+        </p:txBody>
       </p:sp>
       <p:sp>
         <p:nvSpPr>
@@ -4863,6 +4895,10 @@
             </a:outerShdw>
           </a:effectLst>
         </p:spPr>
+        <p:txBody>
+          <a:bodyPr/>
+          <a:p/>
+        </p:txBody>
       </p:sp>
       <p:sp>
         <p:nvSpPr>
@@ -4888,6 +4924,10 @@
             <a:prstDash val="solid"/>
           </a:ln>
         </p:spPr>
+        <p:txBody>
+          <a:bodyPr/>
+          <a:p/>
+        </p:txBody>
       </p:sp>
       <p:sp>
         <p:nvSpPr>
@@ -4998,6 +5038,10 @@
             </a:outerShdw>
           </a:effectLst>
         </p:spPr>
+        <p:txBody>
+          <a:bodyPr/>
+          <a:p/>
+        </p:txBody>
       </p:sp>
       <p:sp>
         <p:nvSpPr>
@@ -5023,6 +5067,10 @@
             <a:prstDash val="solid"/>
           </a:ln>
         </p:spPr>
+        <p:txBody>
+          <a:bodyPr/>
+          <a:p/>
+        </p:txBody>
       </p:sp>
       <p:sp>
         <p:nvSpPr>
@@ -5133,6 +5181,10 @@
             </a:outerShdw>
           </a:effectLst>
         </p:spPr>
+        <p:txBody>
+          <a:bodyPr/>
+          <a:p/>
+        </p:txBody>
       </p:sp>
       <p:sp>
         <p:nvSpPr>
@@ -5158,6 +5210,10 @@
             <a:prstDash val="solid"/>
           </a:ln>
         </p:spPr>
+        <p:txBody>
+          <a:bodyPr/>
+          <a:p/>
+        </p:txBody>
       </p:sp>
       <p:sp>
         <p:nvSpPr>
@@ -5378,6 +5434,10 @@
             </a:outerShdw>
           </a:effectLst>
         </p:spPr>
+        <p:txBody>
+          <a:bodyPr/>
+          <a:p/>
+        </p:txBody>
       </p:sp>
       <p:sp>
         <p:nvSpPr>
@@ -5403,6 +5463,10 @@
             <a:prstDash val="solid"/>
           </a:ln>
         </p:spPr>
+        <p:txBody>
+          <a:bodyPr/>
+          <a:p/>
+        </p:txBody>
       </p:sp>
       <p:sp>
         <p:nvSpPr>
@@ -5513,6 +5577,10 @@
             </a:outerShdw>
           </a:effectLst>
         </p:spPr>
+        <p:txBody>
+          <a:bodyPr/>
+          <a:p/>
+        </p:txBody>
       </p:sp>
       <p:sp>
         <p:nvSpPr>
@@ -5538,6 +5606,10 @@
             <a:prstDash val="solid"/>
           </a:ln>
         </p:spPr>
+        <p:txBody>
+          <a:bodyPr/>
+          <a:p/>
+        </p:txBody>
       </p:sp>
       <p:sp>
         <p:nvSpPr>
@@ -5648,6 +5720,10 @@
             </a:outerShdw>
           </a:effectLst>
         </p:spPr>
+        <p:txBody>
+          <a:bodyPr/>
+          <a:p/>
+        </p:txBody>
       </p:sp>
       <p:sp>
         <p:nvSpPr>
@@ -5673,6 +5749,10 @@
             <a:prstDash val="solid"/>
           </a:ln>
         </p:spPr>
+        <p:txBody>
+          <a:bodyPr/>
+          <a:p/>
+        </p:txBody>
       </p:sp>
       <p:sp>
         <p:nvSpPr>
@@ -5783,6 +5863,10 @@
             </a:outerShdw>
           </a:effectLst>
         </p:spPr>
+        <p:txBody>
+          <a:bodyPr/>
+          <a:p/>
+        </p:txBody>
       </p:sp>
       <p:sp>
         <p:nvSpPr>
@@ -5808,6 +5892,10 @@
             <a:prstDash val="solid"/>
           </a:ln>
         </p:spPr>
+        <p:txBody>
+          <a:bodyPr/>
+          <a:p/>
+        </p:txBody>
       </p:sp>
       <p:sp>
         <p:nvSpPr>
@@ -6028,6 +6116,10 @@
             </a:outerShdw>
           </a:effectLst>
         </p:spPr>
+        <p:txBody>
+          <a:bodyPr/>
+          <a:p/>
+        </p:txBody>
       </p:sp>
       <p:sp>
         <p:nvSpPr>
@@ -6645,6 +6737,10 @@
             </a:outerShdw>
           </a:effectLst>
         </p:spPr>
+        <p:txBody>
+          <a:bodyPr/>
+          <a:p/>
+        </p:txBody>
       </p:sp>
       <p:sp>
         <p:nvSpPr>
@@ -7262,6 +7358,10 @@
             </a:outerShdw>
           </a:effectLst>
         </p:spPr>
+        <p:txBody>
+          <a:bodyPr/>
+          <a:p/>
+        </p:txBody>
       </p:sp>
       <p:sp>
         <p:nvSpPr>
@@ -7373,18 +7473,58 @@
           </a:p>
         </p:txBody>
       </p:sp>
+      <p:sp>
+        <p:nvSpPr>
+          <p:cNvPr id="4" name="Text 1"/>
+          <p:cNvSpPr/>
+          <p:nvPr/>
+        </p:nvSpPr>
+        <p:spPr>
+          <a:xfrm>
+            <a:off x="320040" y="4800600"/>
+            <a:ext cx="8503920" cy="256032"/>
+          </a:xfrm>
+          <a:prstGeom prst="rect">
+            <a:avLst/>
+          </a:prstGeom>
+          <a:noFill/>
+          <a:ln/>
+        </p:spPr>
+        <p:txBody>
+          <a:bodyPr wrap="square" lIns="0" tIns="0" rIns="0" bIns="0" rtlCol="0" anchor="ctr"/>
+          <a:lstStyle/>
+          <a:p>
+            <a:pPr algn="ctr" indent="0" marL="0">
+              <a:buNone/>
+            </a:pPr>
+            <a:r>
+              <a:rPr lang="en-US" sz="1000" i="1" dirty="0">
+                <a:solidFill>
+                  <a:srgbClr val="8B949E"/>
+                </a:solidFill>
+                <a:latin typeface="Calibri" pitchFamily="34" charset="0"/>
+                <a:ea typeface="Calibri" pitchFamily="34" charset="-122"/>
+                <a:cs typeface="Calibri" pitchFamily="34" charset="-120"/>
+              </a:rPr>
+              <a:t>Interactive date slicer filters all visuals simultaneously  ·  Built with Power BI Desktop  ·  Data source: EGX30_cleaned.csv</a:t>
+            </a:r>
+            <a:endParaRPr lang="en-US" sz="1000" dirty="0"/>
+          </a:p>
+        </p:txBody>
+      </p:sp>
       <p:pic>
         <p:nvPicPr>
-          <p:cNvPr id="3" name="Image 0" descr="/mnt/user-data/uploads/1778205291475_image.png">    </p:cNvPr>
+          <p:cNvPr id="5" name="Picture 4" descr="EGX30_Dashboard_PBI.png"/>
           <p:cNvPicPr>
             <a:picLocks noChangeAspect="1"/>
           </p:cNvPicPr>
           <p:nvPr/>
         </p:nvPicPr>
         <p:blipFill>
-          <a:blip r:embed="rId1"/>
-          <a:srcRect l="0" r="0" t="0" b="0"/>
-          <a:stretch/>
+          <a:blip r:embed="rId4"/>
+          <a:stretch>
+            <a:fillRect/>
+          </a:stretch>
         </p:blipFill>
         <p:spPr>
           <a:xfrm>
@@ -7396,45 +7536,6 @@
           </a:prstGeom>
         </p:spPr>
       </p:pic>
-      <p:sp>
-        <p:nvSpPr>
-          <p:cNvPr id="4" name="Text 1"/>
-          <p:cNvSpPr/>
-          <p:nvPr/>
-        </p:nvSpPr>
-        <p:spPr>
-          <a:xfrm>
-            <a:off x="320040" y="4800600"/>
-            <a:ext cx="8503920" cy="256032"/>
-          </a:xfrm>
-          <a:prstGeom prst="rect">
-            <a:avLst/>
-          </a:prstGeom>
-          <a:noFill/>
-          <a:ln/>
-        </p:spPr>
-        <p:txBody>
-          <a:bodyPr wrap="square" lIns="0" tIns="0" rIns="0" bIns="0" rtlCol="0" anchor="ctr"/>
-          <a:lstStyle/>
-          <a:p>
-            <a:pPr algn="ctr" indent="0" marL="0">
-              <a:buNone/>
-            </a:pPr>
-            <a:r>
-              <a:rPr lang="en-US" sz="1000" i="1" dirty="0">
-                <a:solidFill>
-                  <a:srgbClr val="8B949E"/>
-                </a:solidFill>
-                <a:latin typeface="Calibri" pitchFamily="34" charset="0"/>
-                <a:ea typeface="Calibri" pitchFamily="34" charset="-122"/>
-                <a:cs typeface="Calibri" pitchFamily="34" charset="-120"/>
-              </a:rPr>
-              <a:t>Interactive date slicer filters all visuals simultaneously  ·  Built with Power BI Desktop  ·  Data source: EGX30_cleaned.csv</a:t>
-            </a:r>
-            <a:endParaRPr lang="en-US" sz="1000" dirty="0"/>
-          </a:p>
-        </p:txBody>
-      </p:sp>
     </p:spTree>
   </p:cSld>
   <p:clrMapOvr>
@@ -7537,6 +7638,10 @@
             </a:outerShdw>
           </a:effectLst>
         </p:spPr>
+        <p:txBody>
+          <a:bodyPr/>
+          <a:p/>
+        </p:txBody>
       </p:sp>
       <p:sp>
         <p:nvSpPr>
@@ -7562,6 +7667,10 @@
             <a:prstDash val="solid"/>
           </a:ln>
         </p:spPr>
+        <p:txBody>
+          <a:bodyPr/>
+          <a:p/>
+        </p:txBody>
       </p:sp>
       <p:sp>
         <p:nvSpPr>
@@ -7596,7 +7705,7 @@
                 <a:ea typeface="Calibri" pitchFamily="34" charset="-122"/>
                 <a:cs typeface="Calibri" pitchFamily="34" charset="-120"/>
               </a:rPr>
-              <a:t>Strong nominal return, weak risk-adjusted performance</a:t>
+              <a:t>Strong nominal return, near-zero risk-adjusted performance</a:t>
             </a:r>
             <a:endParaRPr lang="en-US" sz="1200" dirty="0"/>
           </a:p>
@@ -7635,7 +7744,7 @@
                 <a:ea typeface="Calibri" pitchFamily="34" charset="-122"/>
                 <a:cs typeface="Calibri" pitchFamily="34" charset="-120"/>
               </a:rPr>
-              <a:t>EGX30 delivered 666.9% total return (17.16% annualized) but a Sharpe of -0.45 with RF=27% means Egyptian T-bills outperformed on a risk-adjusted basis.</a:t>
+              <a:t>EGX30 delivered 666.9% total return (17.16% annualized) but a Sharpe of +0.10 with RF=15.06% means Egyptian index barely compensated investors for the volatility and drawdown risk taken.</a:t>
             </a:r>
             <a:endParaRPr lang="en-US" sz="1050" dirty="0"/>
           </a:p>
@@ -7672,6 +7781,10 @@
             </a:outerShdw>
           </a:effectLst>
         </p:spPr>
+        <p:txBody>
+          <a:bodyPr/>
+          <a:p/>
+        </p:txBody>
       </p:sp>
       <p:sp>
         <p:nvSpPr>
@@ -7697,6 +7810,10 @@
             <a:prstDash val="solid"/>
           </a:ln>
         </p:spPr>
+        <p:txBody>
+          <a:bodyPr/>
+          <a:p/>
+        </p:txBody>
       </p:sp>
       <p:sp>
         <p:nvSpPr>
@@ -7807,6 +7924,10 @@
             </a:outerShdw>
           </a:effectLst>
         </p:spPr>
+        <p:txBody>
+          <a:bodyPr/>
+          <a:p/>
+        </p:txBody>
       </p:sp>
       <p:sp>
         <p:nvSpPr>
@@ -7832,6 +7953,10 @@
             <a:prstDash val="solid"/>
           </a:ln>
         </p:spPr>
+        <p:txBody>
+          <a:bodyPr/>
+          <a:p/>
+        </p:txBody>
       </p:sp>
       <p:sp>
         <p:nvSpPr>
@@ -7942,6 +8067,10 @@
             </a:outerShdw>
           </a:effectLst>
         </p:spPr>
+        <p:txBody>
+          <a:bodyPr/>
+          <a:p/>
+        </p:txBody>
       </p:sp>
       <p:sp>
         <p:nvSpPr>
@@ -7967,6 +8096,10 @@
             <a:prstDash val="solid"/>
           </a:ln>
         </p:spPr>
+        <p:txBody>
+          <a:bodyPr/>
+          <a:p/>
+        </p:txBody>
       </p:sp>
       <p:sp>
         <p:nvSpPr>
@@ -8077,6 +8210,10 @@
             </a:outerShdw>
           </a:effectLst>
         </p:spPr>
+        <p:txBody>
+          <a:bodyPr/>
+          <a:p/>
+        </p:txBody>
       </p:sp>
       <p:sp>
         <p:nvSpPr>
@@ -8102,6 +8239,10 @@
             <a:prstDash val="solid"/>
           </a:ln>
         </p:spPr>
+        <p:txBody>
+          <a:bodyPr/>
+          <a:p/>
+        </p:txBody>
       </p:sp>
       <p:sp>
         <p:nvSpPr>
@@ -8237,6 +8378,10 @@
             <a:prstDash val="solid"/>
           </a:ln>
         </p:spPr>
+        <p:txBody>
+          <a:bodyPr/>
+          <a:p/>
+        </p:txBody>
       </p:sp>
       <p:sp>
         <p:nvSpPr>
@@ -8340,6 +8485,10 @@
             <a:prstDash val="solid"/>
           </a:ln>
         </p:spPr>
+        <p:txBody>
+          <a:bodyPr/>
+          <a:p/>
+        </p:txBody>
       </p:sp>
       <p:sp>
         <p:nvSpPr>
@@ -8755,6 +8904,10 @@
             </a:outerShdw>
           </a:effectLst>
         </p:spPr>
+        <p:txBody>
+          <a:bodyPr/>
+          <a:p/>
+        </p:txBody>
       </p:sp>
       <p:sp>
         <p:nvSpPr>
@@ -8904,6 +9057,10 @@
             </a:outerShdw>
           </a:effectLst>
         </p:spPr>
+        <p:txBody>
+          <a:bodyPr/>
+          <a:p/>
+        </p:txBody>
       </p:sp>
       <p:sp>
         <p:nvSpPr>
@@ -9053,6 +9210,10 @@
             </a:outerShdw>
           </a:effectLst>
         </p:spPr>
+        <p:txBody>
+          <a:bodyPr/>
+          <a:p/>
+        </p:txBody>
       </p:sp>
       <p:sp>
         <p:nvSpPr>
@@ -9202,6 +9363,10 @@
             </a:outerShdw>
           </a:effectLst>
         </p:spPr>
+        <p:txBody>
+          <a:bodyPr/>
+          <a:p/>
+        </p:txBody>
       </p:sp>
       <p:sp>
         <p:nvSpPr>
@@ -9351,6 +9516,10 @@
             </a:outerShdw>
           </a:effectLst>
         </p:spPr>
+        <p:txBody>
+          <a:bodyPr/>
+          <a:p/>
+        </p:txBody>
       </p:sp>
       <p:sp>
         <p:nvSpPr>
@@ -9500,6 +9669,10 @@
             </a:outerShdw>
           </a:effectLst>
         </p:spPr>
+        <p:txBody>
+          <a:bodyPr/>
+          <a:p/>
+        </p:txBody>
       </p:sp>
       <p:sp>
         <p:nvSpPr>
@@ -9649,6 +9822,10 @@
             </a:outerShdw>
           </a:effectLst>
         </p:spPr>
+        <p:txBody>
+          <a:bodyPr/>
+          <a:p/>
+        </p:txBody>
       </p:sp>
       <p:sp>
         <p:nvSpPr>
@@ -9869,6 +10046,10 @@
             </a:outerShdw>
           </a:effectLst>
         </p:spPr>
+        <p:txBody>
+          <a:bodyPr/>
+          <a:p/>
+        </p:txBody>
       </p:sp>
       <p:sp>
         <p:nvSpPr>
@@ -10067,6 +10248,10 @@
             </a:outerShdw>
           </a:effectLst>
         </p:spPr>
+        <p:txBody>
+          <a:bodyPr/>
+          <a:p/>
+        </p:txBody>
       </p:sp>
       <p:sp>
         <p:nvSpPr>
@@ -10599,6 +10784,10 @@
             </a:outerShdw>
           </a:effectLst>
         </p:spPr>
+        <p:txBody>
+          <a:bodyPr/>
+          <a:p/>
+        </p:txBody>
       </p:sp>
       <p:sp>
         <p:nvSpPr>
@@ -10709,6 +10898,10 @@
             </a:outerShdw>
           </a:effectLst>
         </p:spPr>
+        <p:txBody>
+          <a:bodyPr/>
+          <a:p/>
+        </p:txBody>
       </p:sp>
       <p:sp>
         <p:nvSpPr>
@@ -10819,6 +11012,10 @@
             </a:outerShdw>
           </a:effectLst>
         </p:spPr>
+        <p:txBody>
+          <a:bodyPr/>
+          <a:p/>
+        </p:txBody>
       </p:sp>
       <p:sp>
         <p:nvSpPr>
@@ -10929,6 +11126,10 @@
             </a:outerShdw>
           </a:effectLst>
         </p:spPr>
+        <p:txBody>
+          <a:bodyPr/>
+          <a:p/>
+        </p:txBody>
       </p:sp>
       <p:sp>
         <p:nvSpPr>
@@ -11039,6 +11240,10 @@
             </a:outerShdw>
           </a:effectLst>
         </p:spPr>
+        <p:txBody>
+          <a:bodyPr/>
+          <a:p/>
+        </p:txBody>
       </p:sp>
       <p:sp>
         <p:nvSpPr>
@@ -11073,7 +11278,7 @@
                 <a:ea typeface="Calibri" pitchFamily="34" charset="-122"/>
                 <a:cs typeface="Calibri" pitchFamily="34" charset="-120"/>
               </a:rPr>
-              <a:t>-0.45</a:t>
+              <a:t>+0.10</a:t>
             </a:r>
             <a:endParaRPr lang="en-US" sz="2800" dirty="0"/>
           </a:p>
@@ -11112,7 +11317,7 @@
                 <a:ea typeface="Calibri" pitchFamily="34" charset="-122"/>
                 <a:cs typeface="Calibri" pitchFamily="34" charset="-120"/>
               </a:rPr>
-              <a:t>Sharpe Ratio (RF=27%)</a:t>
+              <a:t>Sharpe Ratio (RF=15.06%)</a:t>
             </a:r>
             <a:endParaRPr lang="en-US" sz="1100" dirty="0"/>
           </a:p>
@@ -11149,6 +11354,10 @@
             </a:outerShdw>
           </a:effectLst>
         </p:spPr>
+        <p:txBody>
+          <a:bodyPr/>
+          <a:p/>
+        </p:txBody>
       </p:sp>
       <p:sp>
         <p:nvSpPr>
@@ -11261,7 +11470,7 @@
                 <a:ea typeface="Calibri" pitchFamily="34" charset="-122"/>
                 <a:cs typeface="Calibri" pitchFamily="34" charset="-120"/>
               </a:rPr>
-              <a:t>Sharpe ratio uses Egyptian T-bill rate (RF = 27%) as risk-free benchmark</a:t>
+              <a:t>Sharpe ratio uses Egyptian T-bill rate (RF = 15.06%) as risk-free benchmark</a:t>
             </a:r>
             <a:endParaRPr lang="en-US" sz="1000" dirty="0"/>
           </a:p>
@@ -11369,6 +11578,10 @@
             </a:outerShdw>
           </a:effectLst>
         </p:spPr>
+        <p:txBody>
+          <a:bodyPr/>
+          <a:p/>
+        </p:txBody>
       </p:sp>
       <p:graphicFrame>
         <p:nvGraphicFramePr>
@@ -11641,6 +11854,10 @@
             </a:outerShdw>
           </a:effectLst>
         </p:spPr>
+        <p:txBody>
+          <a:bodyPr/>
+          <a:p/>
+        </p:txBody>
       </p:sp>
       <p:sp>
         <p:nvSpPr>
@@ -11666,6 +11883,10 @@
             <a:prstDash val="solid"/>
           </a:ln>
         </p:spPr>
+        <p:txBody>
+          <a:bodyPr/>
+          <a:p/>
+        </p:txBody>
       </p:sp>
       <p:sp>
         <p:nvSpPr>
@@ -11737,6 +11958,10 @@
             </a:outerShdw>
           </a:effectLst>
         </p:spPr>
+        <p:txBody>
+          <a:bodyPr/>
+          <a:p/>
+        </p:txBody>
       </p:sp>
       <p:sp>
         <p:nvSpPr>
@@ -11762,6 +11987,10 @@
             <a:prstDash val="solid"/>
           </a:ln>
         </p:spPr>
+        <p:txBody>
+          <a:bodyPr/>
+          <a:p/>
+        </p:txBody>
       </p:sp>
       <p:sp>
         <p:nvSpPr>
@@ -11904,6 +12133,10 @@
             </a:outerShdw>
           </a:effectLst>
         </p:spPr>
+        <p:txBody>
+          <a:bodyPr/>
+          <a:p/>
+        </p:txBody>
       </p:sp>
       <p:sp>
         <p:nvSpPr>
@@ -12521,6 +12754,10 @@
             </a:outerShdw>
           </a:effectLst>
         </p:spPr>
+        <p:txBody>
+          <a:bodyPr/>
+          <a:p/>
+        </p:txBody>
       </p:sp>
       <p:sp>
         <p:nvSpPr>
@@ -12585,6 +12822,10 @@
             <a:prstDash val="solid"/>
           </a:ln>
         </p:spPr>
+        <p:txBody>
+          <a:bodyPr/>
+          <a:p/>
+        </p:txBody>
       </p:sp>
       <p:sp>
         <p:nvSpPr>
@@ -12688,6 +12929,10 @@
             <a:prstDash val="solid"/>
           </a:ln>
         </p:spPr>
+        <p:txBody>
+          <a:bodyPr/>
+          <a:p/>
+        </p:txBody>
       </p:sp>
       <p:sp>
         <p:nvSpPr>
@@ -12791,6 +13036,10 @@
             <a:prstDash val="solid"/>
           </a:ln>
         </p:spPr>
+        <p:txBody>
+          <a:bodyPr/>
+          <a:p/>
+        </p:txBody>
       </p:sp>
       <p:sp>
         <p:nvSpPr>
@@ -12894,6 +13143,10 @@
             <a:prstDash val="solid"/>
           </a:ln>
         </p:spPr>
+        <p:txBody>
+          <a:bodyPr/>
+          <a:p/>
+        </p:txBody>
       </p:sp>
       <p:sp>
         <p:nvSpPr>
@@ -13075,6 +13328,10 @@
             </a:outerShdw>
           </a:effectLst>
         </p:spPr>
+        <p:txBody>
+          <a:bodyPr/>
+          <a:p/>
+        </p:txBody>
       </p:sp>
       <p:sp>
         <p:nvSpPr>
@@ -13162,6 +13419,10 @@
             </a:outerShdw>
           </a:effectLst>
         </p:spPr>
+        <p:txBody>
+          <a:bodyPr/>
+          <a:p/>
+        </p:txBody>
       </p:sp>
       <p:sp>
         <p:nvSpPr>
@@ -13249,6 +13510,10 @@
             </a:outerShdw>
           </a:effectLst>
         </p:spPr>
+        <p:txBody>
+          <a:bodyPr/>
+          <a:p/>
+        </p:txBody>
       </p:sp>
       <p:sp>
         <p:nvSpPr>
@@ -13274,6 +13539,10 @@
             <a:prstDash val="solid"/>
           </a:ln>
         </p:spPr>
+        <p:txBody>
+          <a:bodyPr/>
+          <a:p/>
+        </p:txBody>
       </p:sp>
       <p:sp>
         <p:nvSpPr>
@@ -13384,6 +13653,10 @@
             </a:outerShdw>
           </a:effectLst>
         </p:spPr>
+        <p:txBody>
+          <a:bodyPr/>
+          <a:p/>
+        </p:txBody>
       </p:sp>
       <p:sp>
         <p:nvSpPr>
@@ -13409,6 +13682,10 @@
             <a:prstDash val="solid"/>
           </a:ln>
         </p:spPr>
+        <p:txBody>
+          <a:bodyPr/>
+          <a:p/>
+        </p:txBody>
       </p:sp>
       <p:sp>
         <p:nvSpPr>
@@ -13590,6 +13867,10 @@
             </a:outerShdw>
           </a:effectLst>
         </p:spPr>
+        <p:txBody>
+          <a:bodyPr/>
+          <a:p/>
+        </p:txBody>
       </p:sp>
       <p:sp>
         <p:nvSpPr>
@@ -13872,6 +14153,10 @@
             </a:outerShdw>
           </a:effectLst>
         </p:spPr>
+        <p:txBody>
+          <a:bodyPr/>
+          <a:p/>
+        </p:txBody>
       </p:sp>
       <p:sp>
         <p:nvSpPr>
@@ -14271,6 +14556,10 @@
             </a:outerShdw>
           </a:effectLst>
         </p:spPr>
+        <p:txBody>
+          <a:bodyPr/>
+          <a:p/>
+        </p:txBody>
       </p:sp>
       <p:sp>
         <p:nvSpPr>
@@ -14296,6 +14585,10 @@
             <a:prstDash val="solid"/>
           </a:ln>
         </p:spPr>
+        <p:txBody>
+          <a:bodyPr/>
+          <a:p/>
+        </p:txBody>
       </p:sp>
       <p:sp>
         <p:nvSpPr>
@@ -14466,6 +14759,10 @@
             </a:outerShdw>
           </a:effectLst>
         </p:spPr>
+        <p:txBody>
+          <a:bodyPr/>
+          <a:p/>
+        </p:txBody>
       </p:sp>
       <p:sp>
         <p:nvSpPr>
@@ -14500,7 +14797,7 @@
                 <a:ea typeface="Calibri" pitchFamily="34" charset="-122"/>
                 <a:cs typeface="Calibri" pitchFamily="34" charset="-120"/>
               </a:rPr>
-              <a:t>-0.45</a:t>
+              <a:t>+0.10</a:t>
             </a:r>
             <a:endParaRPr lang="en-US" sz="2800" dirty="0"/>
           </a:p>
@@ -14539,7 +14836,7 @@
                 <a:ea typeface="Calibri" pitchFamily="34" charset="-122"/>
                 <a:cs typeface="Calibri" pitchFamily="34" charset="-120"/>
               </a:rPr>
-              <a:t>Sharpe Ratio (RF=27%)</a:t>
+              <a:t>Sharpe Ratio (RF=15.06%)</a:t>
             </a:r>
             <a:endParaRPr lang="en-US" sz="1100" dirty="0"/>
           </a:p>
@@ -14576,6 +14873,10 @@
             </a:outerShdw>
           </a:effectLst>
         </p:spPr>
+        <p:txBody>
+          <a:bodyPr/>
+          <a:p/>
+        </p:txBody>
       </p:sp>
       <p:sp>
         <p:nvSpPr>
@@ -14686,6 +14987,10 @@
             </a:outerShdw>
           </a:effectLst>
         </p:spPr>
+        <p:txBody>
+          <a:bodyPr/>
+          <a:p/>
+        </p:txBody>
       </p:sp>
       <p:sp>
         <p:nvSpPr>
@@ -14796,6 +15101,10 @@
             </a:outerShdw>
           </a:effectLst>
         </p:spPr>
+        <p:txBody>
+          <a:bodyPr/>
+          <a:p/>
+        </p:txBody>
       </p:sp>
       <p:sp>
         <p:nvSpPr>
@@ -14906,6 +15215,10 @@
             </a:outerShdw>
           </a:effectLst>
         </p:spPr>
+        <p:txBody>
+          <a:bodyPr/>
+          <a:p/>
+        </p:txBody>
       </p:sp>
       <p:sp>
         <p:nvSpPr>

</xml_diff>